<commit_message>
Phase D prep: correct GitHub URL in PPTX and regenerate presentation
</commit_message>
<xml_diff>
--- a/outputs/TCGA_KIRC_Presentation.pptx
+++ b/outputs/TCGA_KIRC_Presentation.pptx
@@ -3684,7 +3684,7 @@
                 </a:solidFill>
               </a:rPr>
               <a:t>2.  Project GitHub Repository:
-     https://github.com/[USERNAME]/tcga-kirc-project</a:t>
+     https://github.com/LikithaDudala/tcga-kirc-project</a:t>
             </a:r>
           </a:p>
           <a:p>
@@ -4117,7 +4117,7 @@
                   <a:srgbClr val="BBD4FF"/>
                 </a:solidFill>
               </a:rPr>
-              <a:t>GitHub:  https://github.com/[USERNAME]/tcga-kirc-project</a:t>
+              <a:t>GitHub:  https://github.com/LikithaDudala/tcga-kirc-project</a:t>
             </a:r>
           </a:p>
         </p:txBody>

</xml_diff>